<commit_message>
GitHub bağlantısı ekle ve kod/README'de öğrenci numarasını maskele
Rapor ve sunumun kapağına/son slaytına proje deposu bağlantısı eklendi.
kod/README.md'deki öğrenci numarası gizlilik için maskelendi (*********47);
böylece public repoda hiçbir metinde tam numara kalmadı. sunum/ klasöründeki
maskeli kopyalar bağlantı eklenmiş hâliyle yeniden üretildi.
</commit_message>
<xml_diff>
--- a/sunum/Sunum_KubilayInanc.pptx
+++ b/sunum/Sunum_KubilayInanc.pptx
@@ -4270,6 +4270,45 @@
           </a:p>
         </p:txBody>
       </p:sp>
+      <p:sp>
+        <p:nvSpPr>
+          <p:cNvPr id="7" name="Text 5"/>
+          <p:cNvSpPr/>
+          <p:nvPr/>
+        </p:nvSpPr>
+        <p:spPr>
+          <a:xfrm>
+            <a:off x="640080" y="6327648"/>
+            <a:ext cx="10972800" cy="320040"/>
+          </a:xfrm>
+          <a:prstGeom prst="rect">
+            <a:avLst/>
+          </a:prstGeom>
+          <a:noFill/>
+          <a:ln/>
+        </p:spPr>
+        <p:txBody>
+          <a:bodyPr wrap="square" lIns="0" tIns="0" rIns="0" bIns="0" rtlCol="0" anchor="ctr"/>
+          <a:lstStyle/>
+          <a:p>
+            <a:pPr indent="0" marL="0">
+              <a:buNone/>
+            </a:pPr>
+            <a:r>
+              <a:rPr lang="en-US" sz="1200" dirty="0">
+                <a:solidFill>
+                  <a:srgbClr val="CADCFC"/>
+                </a:solidFill>
+                <a:latin typeface="Calibri" pitchFamily="34" charset="0"/>
+                <a:ea typeface="Calibri" pitchFamily="34" charset="-122"/>
+                <a:cs typeface="Calibri" pitchFamily="34" charset="-120"/>
+              </a:rPr>
+              <a:t>Proje kodu: github.com/MandallF/qlearning-vs-sarsa-lavafield</a:t>
+            </a:r>
+            <a:endParaRPr lang="en-US" sz="1200" dirty="0"/>
+          </a:p>
+        </p:txBody>
+      </p:sp>
     </p:spTree>
   </p:cSld>
   <p:clrMapOvr>

</xml_diff>